<commit_message>
Add Cat Bot roam lab, Reddit policy docs, adoptacatbot domain, and layer deck.
Programmatic roam script (Reddit/Places/Yelp), design doc SS12.3-12.6, DreamHost+Railway domain guide, production URL fallbacks, and expanded presentation deck assets.

Co-authored-by: Cursor <cursoragent@cursor.com>
</commit_message>
<xml_diff>
--- a/docs/presentations/band-it-layer-deck/band-it-layer-deck-slide-01.pptx
+++ b/docs/presentations/band-it-layer-deck/band-it-layer-deck-slide-01.pptx
@@ -3104,7 +3104,7 @@
         </p:nvSpPr>
         <p:spPr>
           <a:xfrm>
-            <a:off x="502920" y="384048"/>
+            <a:off x="502920" y="347472"/>
             <a:ext cx="11185855" cy="25400"/>
           </a:xfrm>
           <a:prstGeom prst="rect">
@@ -3147,14 +3147,14 @@
         </p:nvSpPr>
         <p:spPr>
           <a:xfrm>
-            <a:off x="502920" y="438912"/>
+            <a:off x="502920" y="410972"/>
             <a:ext cx="11185855" cy="12700"/>
           </a:xfrm>
           <a:prstGeom prst="rect">
             <a:avLst/>
           </a:prstGeom>
           <a:solidFill>
-            <a:srgbClr val="E0E0E0"/>
+            <a:srgbClr val="0A0A0A"/>
           </a:solidFill>
           <a:ln>
             <a:noFill/>
@@ -3184,14 +3184,111 @@
       </p:sp>
       <p:sp>
         <p:nvSpPr>
-          <p:cNvPr id="4" name="TextBox 3"/>
+          <p:cNvPr id="4" name="Rectangle 3"/>
+          <p:cNvSpPr/>
+          <p:nvPr/>
+        </p:nvSpPr>
+        <p:spPr>
+          <a:xfrm>
+            <a:off x="502920" y="461772"/>
+            <a:ext cx="11185855" cy="12700"/>
+          </a:xfrm>
+          <a:prstGeom prst="rect">
+            <a:avLst/>
+          </a:prstGeom>
+          <a:solidFill>
+            <a:srgbClr val="E0E0E0"/>
+          </a:solidFill>
+          <a:ln>
+            <a:noFill/>
+          </a:ln>
+        </p:spPr>
+        <p:style>
+          <a:lnRef idx="1">
+            <a:schemeClr val="accent1"/>
+          </a:lnRef>
+          <a:fillRef idx="3">
+            <a:schemeClr val="accent1"/>
+          </a:fillRef>
+          <a:effectRef idx="2">
+            <a:schemeClr val="accent1"/>
+          </a:effectRef>
+          <a:fontRef idx="minor">
+            <a:schemeClr val="lt1"/>
+          </a:fontRef>
+        </p:style>
+        <p:txBody>
+          <a:bodyPr rtlCol="0" anchor="ctr"/>
+          <a:lstStyle/>
+          <a:p>
+            <a:pPr algn="ctr"/>
+          </a:p>
+        </p:txBody>
+      </p:sp>
+      <p:sp>
+        <p:nvSpPr>
+          <p:cNvPr id="5" name="Rectangle 4"/>
+          <p:cNvSpPr/>
+          <p:nvPr/>
+        </p:nvSpPr>
+        <p:spPr>
+          <a:xfrm>
+            <a:off x="11185855" y="475488"/>
+            <a:ext cx="502920" cy="292608"/>
+          </a:xfrm>
+          <a:prstGeom prst="rect">
+            <a:avLst/>
+          </a:prstGeom>
+          <a:solidFill>
+            <a:srgbClr val="FFFFFF"/>
+          </a:solidFill>
+          <a:ln w="12700">
+            <a:solidFill>
+              <a:srgbClr val="0A0A0A"/>
+            </a:solidFill>
+          </a:ln>
+        </p:spPr>
+        <p:style>
+          <a:lnRef idx="1">
+            <a:schemeClr val="accent1"/>
+          </a:lnRef>
+          <a:fillRef idx="3">
+            <a:schemeClr val="accent1"/>
+          </a:fillRef>
+          <a:effectRef idx="2">
+            <a:schemeClr val="accent1"/>
+          </a:effectRef>
+          <a:fontRef idx="minor">
+            <a:schemeClr val="lt1"/>
+          </a:fontRef>
+        </p:style>
+        <p:txBody>
+          <a:bodyPr rtlCol="0" anchor="ctr"/>
+          <a:lstStyle/>
+          <a:p>
+            <a:pPr algn="ctr"/>
+            <a:r>
+              <a:rPr sz="1100" b="1">
+                <a:solidFill>
+                  <a:srgbClr val="0014FF"/>
+                </a:solidFill>
+                <a:latin typeface="Consolas"/>
+              </a:rPr>
+              <a:t>01</a:t>
+            </a:r>
+          </a:p>
+        </p:txBody>
+      </p:sp>
+      <p:sp>
+        <p:nvSpPr>
+          <p:cNvPr id="6" name="TextBox 5"/>
           <p:cNvSpPr txBox="1"/>
           <p:nvPr/>
         </p:nvSpPr>
         <p:spPr>
           <a:xfrm>
-            <a:off x="502920" y="530352"/>
-            <a:ext cx="11185855" cy="320040"/>
+            <a:off x="502920" y="822960"/>
+            <a:ext cx="10545775" cy="320040"/>
           </a:xfrm>
           <a:prstGeom prst="rect">
             <a:avLst/>
@@ -3212,27 +3309,27 @@
                 </a:solidFill>
                 <a:latin typeface="Consolas"/>
               </a:rPr>
-              <a:t>FIG. 1 — THE LINE OUTSIDE THE ENTRANCE (TOO MUCH NOISE, ONE DOOR IN)</a:t>
-            </a:r>
-          </a:p>
-        </p:txBody>
-      </p:sp>
-      <p:sp>
-        <p:nvSpPr>
-          <p:cNvPr id="5" name="Rectangle 4"/>
+              <a:t>NO-IMAGE</a:t>
+            </a:r>
+          </a:p>
+        </p:txBody>
+      </p:sp>
+      <p:sp>
+        <p:nvSpPr>
+          <p:cNvPr id="7" name="Rectangle 6"/>
           <p:cNvSpPr/>
           <p:nvPr/>
         </p:nvSpPr>
         <p:spPr>
           <a:xfrm>
-            <a:off x="502920" y="960120"/>
-            <a:ext cx="50800" cy="1417320"/>
+            <a:off x="6876726" y="868680"/>
+            <a:ext cx="12700" cy="5623560"/>
           </a:xfrm>
           <a:prstGeom prst="rect">
             <a:avLst/>
           </a:prstGeom>
           <a:solidFill>
-            <a:srgbClr val="FFDD00"/>
+            <a:srgbClr val="E0E0E0"/>
           </a:solidFill>
           <a:ln>
             <a:noFill/>
@@ -3262,14 +3359,57 @@
       </p:sp>
       <p:sp>
         <p:nvSpPr>
-          <p:cNvPr id="6" name="TextBox 5"/>
+          <p:cNvPr id="8" name="Rectangle 7"/>
+          <p:cNvSpPr/>
+          <p:nvPr/>
+        </p:nvSpPr>
+        <p:spPr>
+          <a:xfrm>
+            <a:off x="502920" y="960120"/>
+            <a:ext cx="50800" cy="1417320"/>
+          </a:xfrm>
+          <a:prstGeom prst="rect">
+            <a:avLst/>
+          </a:prstGeom>
+          <a:solidFill>
+            <a:srgbClr val="FFDD00"/>
+          </a:solidFill>
+          <a:ln>
+            <a:noFill/>
+          </a:ln>
+        </p:spPr>
+        <p:style>
+          <a:lnRef idx="1">
+            <a:schemeClr val="accent1"/>
+          </a:lnRef>
+          <a:fillRef idx="3">
+            <a:schemeClr val="accent1"/>
+          </a:fillRef>
+          <a:effectRef idx="2">
+            <a:schemeClr val="accent1"/>
+          </a:effectRef>
+          <a:fontRef idx="minor">
+            <a:schemeClr val="lt1"/>
+          </a:fontRef>
+        </p:style>
+        <p:txBody>
+          <a:bodyPr rtlCol="0" anchor="ctr"/>
+          <a:lstStyle/>
+          <a:p>
+            <a:pPr algn="ctr"/>
+          </a:p>
+        </p:txBody>
+      </p:sp>
+      <p:sp>
+        <p:nvSpPr>
+          <p:cNvPr id="9" name="TextBox 8"/>
           <p:cNvSpPr txBox="1"/>
           <p:nvPr/>
         </p:nvSpPr>
         <p:spPr>
           <a:xfrm>
             <a:off x="630936" y="914400"/>
-            <a:ext cx="6136062" cy="1463040"/>
+            <a:ext cx="6136062" cy="1508760"/>
           </a:xfrm>
           <a:prstGeom prst="rect">
             <a:avLst/>
@@ -3301,14 +3441,188 @@
       </p:sp>
       <p:sp>
         <p:nvSpPr>
-          <p:cNvPr id="7" name="TextBox 6"/>
+          <p:cNvPr id="10" name="Rectangle 9"/>
+          <p:cNvSpPr/>
+          <p:nvPr/>
+        </p:nvSpPr>
+        <p:spPr>
+          <a:xfrm>
+            <a:off x="502920" y="2395728"/>
+            <a:ext cx="6264078" cy="25400"/>
+          </a:xfrm>
+          <a:prstGeom prst="rect">
+            <a:avLst/>
+          </a:prstGeom>
+          <a:solidFill>
+            <a:srgbClr val="0A0A0A"/>
+          </a:solidFill>
+          <a:ln>
+            <a:noFill/>
+          </a:ln>
+        </p:spPr>
+        <p:style>
+          <a:lnRef idx="1">
+            <a:schemeClr val="accent1"/>
+          </a:lnRef>
+          <a:fillRef idx="3">
+            <a:schemeClr val="accent1"/>
+          </a:fillRef>
+          <a:effectRef idx="2">
+            <a:schemeClr val="accent1"/>
+          </a:effectRef>
+          <a:fontRef idx="minor">
+            <a:schemeClr val="lt1"/>
+          </a:fontRef>
+        </p:style>
+        <p:txBody>
+          <a:bodyPr rtlCol="0" anchor="ctr"/>
+          <a:lstStyle/>
+          <a:p>
+            <a:pPr algn="ctr"/>
+          </a:p>
+        </p:txBody>
+      </p:sp>
+      <p:sp>
+        <p:nvSpPr>
+          <p:cNvPr id="11" name="Rectangle 10"/>
+          <p:cNvSpPr/>
+          <p:nvPr/>
+        </p:nvSpPr>
+        <p:spPr>
+          <a:xfrm>
+            <a:off x="502920" y="2450592"/>
+            <a:ext cx="6264078" cy="12700"/>
+          </a:xfrm>
+          <a:prstGeom prst="rect">
+            <a:avLst/>
+          </a:prstGeom>
+          <a:solidFill>
+            <a:srgbClr val="E0E0E0"/>
+          </a:solidFill>
+          <a:ln>
+            <a:noFill/>
+          </a:ln>
+        </p:spPr>
+        <p:style>
+          <a:lnRef idx="1">
+            <a:schemeClr val="accent1"/>
+          </a:lnRef>
+          <a:fillRef idx="3">
+            <a:schemeClr val="accent1"/>
+          </a:fillRef>
+          <a:effectRef idx="2">
+            <a:schemeClr val="accent1"/>
+          </a:effectRef>
+          <a:fontRef idx="minor">
+            <a:schemeClr val="lt1"/>
+          </a:fontRef>
+        </p:style>
+        <p:txBody>
+          <a:bodyPr rtlCol="0" anchor="ctr"/>
+          <a:lstStyle/>
+          <a:p>
+            <a:pPr algn="ctr"/>
+          </a:p>
+        </p:txBody>
+      </p:sp>
+      <p:sp>
+        <p:nvSpPr>
+          <p:cNvPr id="12" name="Rectangle 11"/>
+          <p:cNvSpPr/>
+          <p:nvPr/>
+        </p:nvSpPr>
+        <p:spPr>
+          <a:xfrm>
+            <a:off x="502920" y="2578608"/>
+            <a:ext cx="6264078" cy="3712464"/>
+          </a:xfrm>
+          <a:prstGeom prst="rect">
+            <a:avLst/>
+          </a:prstGeom>
+          <a:solidFill>
+            <a:srgbClr val="FFFFFF"/>
+          </a:solidFill>
+          <a:ln w="12700">
+            <a:solidFill>
+              <a:srgbClr val="E0E0E0"/>
+            </a:solidFill>
+          </a:ln>
+        </p:spPr>
+        <p:style>
+          <a:lnRef idx="1">
+            <a:schemeClr val="accent1"/>
+          </a:lnRef>
+          <a:fillRef idx="3">
+            <a:schemeClr val="accent1"/>
+          </a:fillRef>
+          <a:effectRef idx="2">
+            <a:schemeClr val="accent1"/>
+          </a:effectRef>
+          <a:fontRef idx="minor">
+            <a:schemeClr val="lt1"/>
+          </a:fontRef>
+        </p:style>
+        <p:txBody>
+          <a:bodyPr rtlCol="0" anchor="ctr"/>
+          <a:lstStyle/>
+          <a:p>
+            <a:pPr algn="ctr"/>
+          </a:p>
+        </p:txBody>
+      </p:sp>
+      <p:sp>
+        <p:nvSpPr>
+          <p:cNvPr id="13" name="Rectangle 12"/>
+          <p:cNvSpPr/>
+          <p:nvPr/>
+        </p:nvSpPr>
+        <p:spPr>
+          <a:xfrm>
+            <a:off x="502920" y="2578608"/>
+            <a:ext cx="38100" cy="3712464"/>
+          </a:xfrm>
+          <a:prstGeom prst="rect">
+            <a:avLst/>
+          </a:prstGeom>
+          <a:solidFill>
+            <a:srgbClr val="0014FF"/>
+          </a:solidFill>
+          <a:ln>
+            <a:noFill/>
+          </a:ln>
+        </p:spPr>
+        <p:style>
+          <a:lnRef idx="1">
+            <a:schemeClr val="accent1"/>
+          </a:lnRef>
+          <a:fillRef idx="3">
+            <a:schemeClr val="accent1"/>
+          </a:fillRef>
+          <a:effectRef idx="2">
+            <a:schemeClr val="accent1"/>
+          </a:effectRef>
+          <a:fontRef idx="minor">
+            <a:schemeClr val="lt1"/>
+          </a:fontRef>
+        </p:style>
+        <p:txBody>
+          <a:bodyPr rtlCol="0" anchor="ctr"/>
+          <a:lstStyle/>
+          <a:p>
+            <a:pPr algn="ctr"/>
+          </a:p>
+        </p:txBody>
+      </p:sp>
+      <p:sp>
+        <p:nvSpPr>
+          <p:cNvPr id="14" name="TextBox 13"/>
           <p:cNvSpPr txBox="1"/>
           <p:nvPr/>
         </p:nvSpPr>
         <p:spPr>
           <a:xfrm>
-            <a:off x="502920" y="2514600"/>
-            <a:ext cx="6264078" cy="3840480"/>
+            <a:off x="612648" y="2670048"/>
+            <a:ext cx="6081198" cy="3575304"/>
           </a:xfrm>
           <a:prstGeom prst="rect">
             <a:avLst/>
@@ -3412,7 +3726,7 @@
                 </a:solidFill>
                 <a:latin typeface="Georgia"/>
               </a:rPr>
-              <a:t>News articles.</a:t>
+              <a:t>—  News articles.</a:t>
             </a:r>
           </a:p>
           <a:p>
@@ -3431,7 +3745,7 @@
                 </a:solidFill>
                 <a:latin typeface="Georgia"/>
               </a:rPr>
-              <a:t>Government announcements.</a:t>
+              <a:t>—  Government announcements.</a:t>
             </a:r>
           </a:p>
           <a:p>
@@ -3450,7 +3764,7 @@
                 </a:solidFill>
                 <a:latin typeface="Georgia"/>
               </a:rPr>
-              <a:t>Budget approvals.</a:t>
+              <a:t>—  Budget approvals.</a:t>
             </a:r>
           </a:p>
           <a:p>
@@ -3469,7 +3783,7 @@
                 </a:solidFill>
                 <a:latin typeface="Georgia"/>
               </a:rPr>
-              <a:t>Industry changes.</a:t>
+              <a:t>—  Industry changes.</a:t>
             </a:r>
           </a:p>
           <a:p>
@@ -3488,7 +3802,7 @@
                 </a:solidFill>
                 <a:latin typeface="Georgia"/>
               </a:rPr>
-              <a:t>Hiring activity.</a:t>
+              <a:t>—  Hiring activity.</a:t>
             </a:r>
           </a:p>
           <a:p>
@@ -3507,7 +3821,7 @@
                 </a:solidFill>
                 <a:latin typeface="Georgia"/>
               </a:rPr>
-              <a:t>Competitive movements.</a:t>
+              <a:t>—  Competitive movements.</a:t>
             </a:r>
           </a:p>
           <a:p>
@@ -3526,21 +3840,21 @@
                 </a:solidFill>
                 <a:latin typeface="Georgia"/>
               </a:rPr>
-              <a:t>Customer interactions.</a:t>
-            </a:r>
-          </a:p>
-        </p:txBody>
-      </p:sp>
-      <p:sp>
-        <p:nvSpPr>
-          <p:cNvPr id="8" name="Rectangle 7"/>
+              <a:t>—  Customer interactions.</a:t>
+            </a:r>
+          </a:p>
+        </p:txBody>
+      </p:sp>
+      <p:sp>
+        <p:nvSpPr>
+          <p:cNvPr id="15" name="Rectangle 14"/>
           <p:cNvSpPr/>
           <p:nvPr/>
         </p:nvSpPr>
         <p:spPr>
           <a:xfrm>
-            <a:off x="6949878" y="914400"/>
-            <a:ext cx="4738897" cy="5349240"/>
+            <a:off x="6968166" y="914400"/>
+            <a:ext cx="4720609" cy="5349240"/>
           </a:xfrm>
           <a:prstGeom prst="rect">
             <a:avLst/>
@@ -3576,40 +3890,61 @@
           </a:p>
         </p:txBody>
       </p:sp>
-      <p:pic>
-        <p:nvPicPr>
-          <p:cNvPr id="9" name="Picture 8" descr="slide-01-newsroom-noise.jpg"/>
-          <p:cNvPicPr>
-            <a:picLocks noChangeAspect="1"/>
-          </p:cNvPicPr>
+      <p:sp>
+        <p:nvSpPr>
+          <p:cNvPr id="16" name="Rectangle 15"/>
+          <p:cNvSpPr/>
           <p:nvPr/>
-        </p:nvPicPr>
-        <p:blipFill>
-          <a:blip r:embed="rId2"/>
-          <a:stretch>
-            <a:fillRect/>
-          </a:stretch>
-        </p:blipFill>
-        <p:spPr>
-          <a:xfrm>
-            <a:off x="7023030" y="1024128"/>
-            <a:ext cx="4592593" cy="4892040"/>
+        </p:nvSpPr>
+        <p:spPr>
+          <a:xfrm>
+            <a:off x="7023030" y="969264"/>
+            <a:ext cx="4610881" cy="5239512"/>
           </a:xfrm>
           <a:prstGeom prst="rect">
             <a:avLst/>
           </a:prstGeom>
-        </p:spPr>
-      </p:pic>
-      <p:sp>
-        <p:nvSpPr>
-          <p:cNvPr id="10" name="TextBox 9"/>
+          <a:solidFill>
+            <a:srgbClr val="FAFAFA"/>
+          </a:solidFill>
+          <a:ln w="12700">
+            <a:solidFill>
+              <a:srgbClr val="E0E0E0"/>
+            </a:solidFill>
+          </a:ln>
+        </p:spPr>
+        <p:style>
+          <a:lnRef idx="1">
+            <a:schemeClr val="accent1"/>
+          </a:lnRef>
+          <a:fillRef idx="3">
+            <a:schemeClr val="accent1"/>
+          </a:fillRef>
+          <a:effectRef idx="2">
+            <a:schemeClr val="accent1"/>
+          </a:effectRef>
+          <a:fontRef idx="minor">
+            <a:schemeClr val="lt1"/>
+          </a:fontRef>
+        </p:style>
+        <p:txBody>
+          <a:bodyPr rtlCol="0" anchor="ctr"/>
+          <a:lstStyle/>
+          <a:p>
+            <a:pPr algn="ctr"/>
+          </a:p>
+        </p:txBody>
+      </p:sp>
+      <p:sp>
+        <p:nvSpPr>
+          <p:cNvPr id="17" name="TextBox 16"/>
           <p:cNvSpPr txBox="1"/>
           <p:nvPr/>
         </p:nvSpPr>
         <p:spPr>
           <a:xfrm>
-            <a:off x="6949878" y="5989320"/>
-            <a:ext cx="4738897" cy="320040"/>
+            <a:off x="7151046" y="1097280"/>
+            <a:ext cx="4354849" cy="256032"/>
           </a:xfrm>
           <a:prstGeom prst="rect">
             <a:avLst/>
@@ -3622,29 +3957,28 @@
           </a:bodyPr>
           <a:lstStyle/>
           <a:p>
-            <a:pPr algn="ctr"/>
-            <a:r>
-              <a:rPr sz="800" b="0">
+            <a:r>
+              <a:rPr sz="700" b="0">
                 <a:solidFill>
                   <a:srgbClr val="5C5C5C"/>
                 </a:solidFill>
                 <a:latin typeface="Consolas"/>
               </a:rPr>
-              <a:t>Fig. 1 — The line outside the entrance (too much noise, one door in)</a:t>
-            </a:r>
-          </a:p>
-        </p:txBody>
-      </p:sp>
-      <p:sp>
-        <p:nvSpPr>
-          <p:cNvPr id="11" name="Rectangle 10"/>
+              <a:t>SIGNAL DESK · INCOMING</a:t>
+            </a:r>
+          </a:p>
+        </p:txBody>
+      </p:sp>
+      <p:sp>
+        <p:nvSpPr>
+          <p:cNvPr id="18" name="Rectangle 17"/>
           <p:cNvSpPr/>
           <p:nvPr/>
         </p:nvSpPr>
         <p:spPr>
           <a:xfrm>
-            <a:off x="502920" y="6510528"/>
-            <a:ext cx="11185855" cy="12700"/>
+            <a:off x="7151046" y="1371600"/>
+            <a:ext cx="4354849" cy="12700"/>
           </a:xfrm>
           <a:prstGeom prst="rect">
             <a:avLst/>
@@ -3680,7 +4014,1451 @@
       </p:sp>
       <p:sp>
         <p:nvSpPr>
-          <p:cNvPr id="12" name="TextBox 11"/>
+          <p:cNvPr id="19" name="Rectangle 18"/>
+          <p:cNvSpPr/>
+          <p:nvPr/>
+        </p:nvSpPr>
+        <p:spPr>
+          <a:xfrm>
+            <a:off x="7151046" y="1481328"/>
+            <a:ext cx="4354849" cy="12700"/>
+          </a:xfrm>
+          <a:prstGeom prst="rect">
+            <a:avLst/>
+          </a:prstGeom>
+          <a:solidFill>
+            <a:srgbClr val="5C5C5C"/>
+          </a:solidFill>
+          <a:ln>
+            <a:noFill/>
+          </a:ln>
+        </p:spPr>
+        <p:style>
+          <a:lnRef idx="1">
+            <a:schemeClr val="accent1"/>
+          </a:lnRef>
+          <a:fillRef idx="3">
+            <a:schemeClr val="accent1"/>
+          </a:fillRef>
+          <a:effectRef idx="2">
+            <a:schemeClr val="accent1"/>
+          </a:effectRef>
+          <a:fontRef idx="minor">
+            <a:schemeClr val="lt1"/>
+          </a:fontRef>
+        </p:style>
+        <p:txBody>
+          <a:bodyPr rtlCol="0" anchor="ctr"/>
+          <a:lstStyle/>
+          <a:p>
+            <a:pPr algn="ctr"/>
+          </a:p>
+        </p:txBody>
+      </p:sp>
+      <p:sp>
+        <p:nvSpPr>
+          <p:cNvPr id="20" name="Rectangle 19"/>
+          <p:cNvSpPr/>
+          <p:nvPr/>
+        </p:nvSpPr>
+        <p:spPr>
+          <a:xfrm>
+            <a:off x="7151046" y="1621028"/>
+            <a:ext cx="4006461" cy="12700"/>
+          </a:xfrm>
+          <a:prstGeom prst="rect">
+            <a:avLst/>
+          </a:prstGeom>
+          <a:solidFill>
+            <a:srgbClr val="E0E0E0"/>
+          </a:solidFill>
+          <a:ln>
+            <a:noFill/>
+          </a:ln>
+        </p:spPr>
+        <p:style>
+          <a:lnRef idx="1">
+            <a:schemeClr val="accent1"/>
+          </a:lnRef>
+          <a:fillRef idx="3">
+            <a:schemeClr val="accent1"/>
+          </a:fillRef>
+          <a:effectRef idx="2">
+            <a:schemeClr val="accent1"/>
+          </a:effectRef>
+          <a:fontRef idx="minor">
+            <a:schemeClr val="lt1"/>
+          </a:fontRef>
+        </p:style>
+        <p:txBody>
+          <a:bodyPr rtlCol="0" anchor="ctr"/>
+          <a:lstStyle/>
+          <a:p>
+            <a:pPr algn="ctr"/>
+          </a:p>
+        </p:txBody>
+      </p:sp>
+      <p:sp>
+        <p:nvSpPr>
+          <p:cNvPr id="21" name="Rectangle 20"/>
+          <p:cNvSpPr/>
+          <p:nvPr/>
+        </p:nvSpPr>
+        <p:spPr>
+          <a:xfrm>
+            <a:off x="7151046" y="1760728"/>
+            <a:ext cx="3396782" cy="12700"/>
+          </a:xfrm>
+          <a:prstGeom prst="rect">
+            <a:avLst/>
+          </a:prstGeom>
+          <a:solidFill>
+            <a:srgbClr val="E0E0E0"/>
+          </a:solidFill>
+          <a:ln>
+            <a:noFill/>
+          </a:ln>
+        </p:spPr>
+        <p:style>
+          <a:lnRef idx="1">
+            <a:schemeClr val="accent1"/>
+          </a:lnRef>
+          <a:fillRef idx="3">
+            <a:schemeClr val="accent1"/>
+          </a:fillRef>
+          <a:effectRef idx="2">
+            <a:schemeClr val="accent1"/>
+          </a:effectRef>
+          <a:fontRef idx="minor">
+            <a:schemeClr val="lt1"/>
+          </a:fontRef>
+        </p:style>
+        <p:txBody>
+          <a:bodyPr rtlCol="0" anchor="ctr"/>
+          <a:lstStyle/>
+          <a:p>
+            <a:pPr algn="ctr"/>
+          </a:p>
+        </p:txBody>
+      </p:sp>
+      <p:sp>
+        <p:nvSpPr>
+          <p:cNvPr id="22" name="Rectangle 21"/>
+          <p:cNvSpPr/>
+          <p:nvPr/>
+        </p:nvSpPr>
+        <p:spPr>
+          <a:xfrm>
+            <a:off x="7151046" y="1900428"/>
+            <a:ext cx="3832267" cy="12700"/>
+          </a:xfrm>
+          <a:prstGeom prst="rect">
+            <a:avLst/>
+          </a:prstGeom>
+          <a:solidFill>
+            <a:srgbClr val="5C5C5C"/>
+          </a:solidFill>
+          <a:ln>
+            <a:noFill/>
+          </a:ln>
+        </p:spPr>
+        <p:style>
+          <a:lnRef idx="1">
+            <a:schemeClr val="accent1"/>
+          </a:lnRef>
+          <a:fillRef idx="3">
+            <a:schemeClr val="accent1"/>
+          </a:fillRef>
+          <a:effectRef idx="2">
+            <a:schemeClr val="accent1"/>
+          </a:effectRef>
+          <a:fontRef idx="minor">
+            <a:schemeClr val="lt1"/>
+          </a:fontRef>
+        </p:style>
+        <p:txBody>
+          <a:bodyPr rtlCol="0" anchor="ctr"/>
+          <a:lstStyle/>
+          <a:p>
+            <a:pPr algn="ctr"/>
+          </a:p>
+        </p:txBody>
+      </p:sp>
+      <p:sp>
+        <p:nvSpPr>
+          <p:cNvPr id="23" name="Rectangle 22"/>
+          <p:cNvSpPr/>
+          <p:nvPr/>
+        </p:nvSpPr>
+        <p:spPr>
+          <a:xfrm>
+            <a:off x="7151046" y="2040128"/>
+            <a:ext cx="2830651" cy="12700"/>
+          </a:xfrm>
+          <a:prstGeom prst="rect">
+            <a:avLst/>
+          </a:prstGeom>
+          <a:solidFill>
+            <a:srgbClr val="E0E0E0"/>
+          </a:solidFill>
+          <a:ln>
+            <a:noFill/>
+          </a:ln>
+        </p:spPr>
+        <p:style>
+          <a:lnRef idx="1">
+            <a:schemeClr val="accent1"/>
+          </a:lnRef>
+          <a:fillRef idx="3">
+            <a:schemeClr val="accent1"/>
+          </a:fillRef>
+          <a:effectRef idx="2">
+            <a:schemeClr val="accent1"/>
+          </a:effectRef>
+          <a:fontRef idx="minor">
+            <a:schemeClr val="lt1"/>
+          </a:fontRef>
+        </p:style>
+        <p:txBody>
+          <a:bodyPr rtlCol="0" anchor="ctr"/>
+          <a:lstStyle/>
+          <a:p>
+            <a:pPr algn="ctr"/>
+          </a:p>
+        </p:txBody>
+      </p:sp>
+      <p:sp>
+        <p:nvSpPr>
+          <p:cNvPr id="24" name="Rectangle 23"/>
+          <p:cNvSpPr/>
+          <p:nvPr/>
+        </p:nvSpPr>
+        <p:spPr>
+          <a:xfrm>
+            <a:off x="7151046" y="2179828"/>
+            <a:ext cx="4137106" cy="12700"/>
+          </a:xfrm>
+          <a:prstGeom prst="rect">
+            <a:avLst/>
+          </a:prstGeom>
+          <a:solidFill>
+            <a:srgbClr val="E0E0E0"/>
+          </a:solidFill>
+          <a:ln>
+            <a:noFill/>
+          </a:ln>
+        </p:spPr>
+        <p:style>
+          <a:lnRef idx="1">
+            <a:schemeClr val="accent1"/>
+          </a:lnRef>
+          <a:fillRef idx="3">
+            <a:schemeClr val="accent1"/>
+          </a:fillRef>
+          <a:effectRef idx="2">
+            <a:schemeClr val="accent1"/>
+          </a:effectRef>
+          <a:fontRef idx="minor">
+            <a:schemeClr val="lt1"/>
+          </a:fontRef>
+        </p:style>
+        <p:txBody>
+          <a:bodyPr rtlCol="0" anchor="ctr"/>
+          <a:lstStyle/>
+          <a:p>
+            <a:pPr algn="ctr"/>
+          </a:p>
+        </p:txBody>
+      </p:sp>
+      <p:sp>
+        <p:nvSpPr>
+          <p:cNvPr id="25" name="Rectangle 24"/>
+          <p:cNvSpPr/>
+          <p:nvPr/>
+        </p:nvSpPr>
+        <p:spPr>
+          <a:xfrm>
+            <a:off x="7151046" y="2319528"/>
+            <a:ext cx="3135491" cy="12700"/>
+          </a:xfrm>
+          <a:prstGeom prst="rect">
+            <a:avLst/>
+          </a:prstGeom>
+          <a:solidFill>
+            <a:srgbClr val="5C5C5C"/>
+          </a:solidFill>
+          <a:ln>
+            <a:noFill/>
+          </a:ln>
+        </p:spPr>
+        <p:style>
+          <a:lnRef idx="1">
+            <a:schemeClr val="accent1"/>
+          </a:lnRef>
+          <a:fillRef idx="3">
+            <a:schemeClr val="accent1"/>
+          </a:fillRef>
+          <a:effectRef idx="2">
+            <a:schemeClr val="accent1"/>
+          </a:effectRef>
+          <a:fontRef idx="minor">
+            <a:schemeClr val="lt1"/>
+          </a:fontRef>
+        </p:style>
+        <p:txBody>
+          <a:bodyPr rtlCol="0" anchor="ctr"/>
+          <a:lstStyle/>
+          <a:p>
+            <a:pPr algn="ctr"/>
+          </a:p>
+        </p:txBody>
+      </p:sp>
+      <p:sp>
+        <p:nvSpPr>
+          <p:cNvPr id="26" name="Rectangle 25"/>
+          <p:cNvSpPr/>
+          <p:nvPr/>
+        </p:nvSpPr>
+        <p:spPr>
+          <a:xfrm>
+            <a:off x="7151046" y="2459228"/>
+            <a:ext cx="3701621" cy="12700"/>
+          </a:xfrm>
+          <a:prstGeom prst="rect">
+            <a:avLst/>
+          </a:prstGeom>
+          <a:solidFill>
+            <a:srgbClr val="E0E0E0"/>
+          </a:solidFill>
+          <a:ln>
+            <a:noFill/>
+          </a:ln>
+        </p:spPr>
+        <p:style>
+          <a:lnRef idx="1">
+            <a:schemeClr val="accent1"/>
+          </a:lnRef>
+          <a:fillRef idx="3">
+            <a:schemeClr val="accent1"/>
+          </a:fillRef>
+          <a:effectRef idx="2">
+            <a:schemeClr val="accent1"/>
+          </a:effectRef>
+          <a:fontRef idx="minor">
+            <a:schemeClr val="lt1"/>
+          </a:fontRef>
+        </p:style>
+        <p:txBody>
+          <a:bodyPr rtlCol="0" anchor="ctr"/>
+          <a:lstStyle/>
+          <a:p>
+            <a:pPr algn="ctr"/>
+          </a:p>
+        </p:txBody>
+      </p:sp>
+      <p:sp>
+        <p:nvSpPr>
+          <p:cNvPr id="27" name="Rectangle 26"/>
+          <p:cNvSpPr/>
+          <p:nvPr/>
+        </p:nvSpPr>
+        <p:spPr>
+          <a:xfrm>
+            <a:off x="7151046" y="2598928"/>
+            <a:ext cx="2612909" cy="12700"/>
+          </a:xfrm>
+          <a:prstGeom prst="rect">
+            <a:avLst/>
+          </a:prstGeom>
+          <a:solidFill>
+            <a:srgbClr val="E0E0E0"/>
+          </a:solidFill>
+          <a:ln>
+            <a:noFill/>
+          </a:ln>
+        </p:spPr>
+        <p:style>
+          <a:lnRef idx="1">
+            <a:schemeClr val="accent1"/>
+          </a:lnRef>
+          <a:fillRef idx="3">
+            <a:schemeClr val="accent1"/>
+          </a:fillRef>
+          <a:effectRef idx="2">
+            <a:schemeClr val="accent1"/>
+          </a:effectRef>
+          <a:fontRef idx="minor">
+            <a:schemeClr val="lt1"/>
+          </a:fontRef>
+        </p:style>
+        <p:txBody>
+          <a:bodyPr rtlCol="0" anchor="ctr"/>
+          <a:lstStyle/>
+          <a:p>
+            <a:pPr algn="ctr"/>
+          </a:p>
+        </p:txBody>
+      </p:sp>
+      <p:sp>
+        <p:nvSpPr>
+          <p:cNvPr id="28" name="Rectangle 27"/>
+          <p:cNvSpPr/>
+          <p:nvPr/>
+        </p:nvSpPr>
+        <p:spPr>
+          <a:xfrm>
+            <a:off x="7151046" y="2738628"/>
+            <a:ext cx="3919364" cy="12700"/>
+          </a:xfrm>
+          <a:prstGeom prst="rect">
+            <a:avLst/>
+          </a:prstGeom>
+          <a:solidFill>
+            <a:srgbClr val="5C5C5C"/>
+          </a:solidFill>
+          <a:ln>
+            <a:noFill/>
+          </a:ln>
+        </p:spPr>
+        <p:style>
+          <a:lnRef idx="1">
+            <a:schemeClr val="accent1"/>
+          </a:lnRef>
+          <a:fillRef idx="3">
+            <a:schemeClr val="accent1"/>
+          </a:fillRef>
+          <a:effectRef idx="2">
+            <a:schemeClr val="accent1"/>
+          </a:effectRef>
+          <a:fontRef idx="minor">
+            <a:schemeClr val="lt1"/>
+          </a:fontRef>
+        </p:style>
+        <p:txBody>
+          <a:bodyPr rtlCol="0" anchor="ctr"/>
+          <a:lstStyle/>
+          <a:p>
+            <a:pPr algn="ctr"/>
+          </a:p>
+        </p:txBody>
+      </p:sp>
+      <p:sp>
+        <p:nvSpPr>
+          <p:cNvPr id="29" name="Rectangle 28"/>
+          <p:cNvSpPr/>
+          <p:nvPr/>
+        </p:nvSpPr>
+        <p:spPr>
+          <a:xfrm>
+            <a:off x="7151046" y="2878328"/>
+            <a:ext cx="3048394" cy="12700"/>
+          </a:xfrm>
+          <a:prstGeom prst="rect">
+            <a:avLst/>
+          </a:prstGeom>
+          <a:solidFill>
+            <a:srgbClr val="E0E0E0"/>
+          </a:solidFill>
+          <a:ln>
+            <a:noFill/>
+          </a:ln>
+        </p:spPr>
+        <p:style>
+          <a:lnRef idx="1">
+            <a:schemeClr val="accent1"/>
+          </a:lnRef>
+          <a:fillRef idx="3">
+            <a:schemeClr val="accent1"/>
+          </a:fillRef>
+          <a:effectRef idx="2">
+            <a:schemeClr val="accent1"/>
+          </a:effectRef>
+          <a:fontRef idx="minor">
+            <a:schemeClr val="lt1"/>
+          </a:fontRef>
+        </p:style>
+        <p:txBody>
+          <a:bodyPr rtlCol="0" anchor="ctr"/>
+          <a:lstStyle/>
+          <a:p>
+            <a:pPr algn="ctr"/>
+          </a:p>
+        </p:txBody>
+      </p:sp>
+      <p:sp>
+        <p:nvSpPr>
+          <p:cNvPr id="30" name="Rectangle 29"/>
+          <p:cNvSpPr/>
+          <p:nvPr/>
+        </p:nvSpPr>
+        <p:spPr>
+          <a:xfrm>
+            <a:off x="7151046" y="3018028"/>
+            <a:ext cx="3570976" cy="12700"/>
+          </a:xfrm>
+          <a:prstGeom prst="rect">
+            <a:avLst/>
+          </a:prstGeom>
+          <a:solidFill>
+            <a:srgbClr val="E0E0E0"/>
+          </a:solidFill>
+          <a:ln>
+            <a:noFill/>
+          </a:ln>
+        </p:spPr>
+        <p:style>
+          <a:lnRef idx="1">
+            <a:schemeClr val="accent1"/>
+          </a:lnRef>
+          <a:fillRef idx="3">
+            <a:schemeClr val="accent1"/>
+          </a:fillRef>
+          <a:effectRef idx="2">
+            <a:schemeClr val="accent1"/>
+          </a:effectRef>
+          <a:fontRef idx="minor">
+            <a:schemeClr val="lt1"/>
+          </a:fontRef>
+        </p:style>
+        <p:txBody>
+          <a:bodyPr rtlCol="0" anchor="ctr"/>
+          <a:lstStyle/>
+          <a:p>
+            <a:pPr algn="ctr"/>
+          </a:p>
+        </p:txBody>
+      </p:sp>
+      <p:sp>
+        <p:nvSpPr>
+          <p:cNvPr id="31" name="Rectangle 30"/>
+          <p:cNvSpPr/>
+          <p:nvPr/>
+        </p:nvSpPr>
+        <p:spPr>
+          <a:xfrm>
+            <a:off x="7151046" y="3157728"/>
+            <a:ext cx="2395166" cy="12700"/>
+          </a:xfrm>
+          <a:prstGeom prst="rect">
+            <a:avLst/>
+          </a:prstGeom>
+          <a:solidFill>
+            <a:srgbClr val="5C5C5C"/>
+          </a:solidFill>
+          <a:ln>
+            <a:noFill/>
+          </a:ln>
+        </p:spPr>
+        <p:style>
+          <a:lnRef idx="1">
+            <a:schemeClr val="accent1"/>
+          </a:lnRef>
+          <a:fillRef idx="3">
+            <a:schemeClr val="accent1"/>
+          </a:fillRef>
+          <a:effectRef idx="2">
+            <a:schemeClr val="accent1"/>
+          </a:effectRef>
+          <a:fontRef idx="minor">
+            <a:schemeClr val="lt1"/>
+          </a:fontRef>
+        </p:style>
+        <p:txBody>
+          <a:bodyPr rtlCol="0" anchor="ctr"/>
+          <a:lstStyle/>
+          <a:p>
+            <a:pPr algn="ctr"/>
+          </a:p>
+        </p:txBody>
+      </p:sp>
+      <p:sp>
+        <p:nvSpPr>
+          <p:cNvPr id="32" name="Rectangle 31"/>
+          <p:cNvSpPr/>
+          <p:nvPr/>
+        </p:nvSpPr>
+        <p:spPr>
+          <a:xfrm>
+            <a:off x="7151046" y="3297428"/>
+            <a:ext cx="3832267" cy="12700"/>
+          </a:xfrm>
+          <a:prstGeom prst="rect">
+            <a:avLst/>
+          </a:prstGeom>
+          <a:solidFill>
+            <a:srgbClr val="E0E0E0"/>
+          </a:solidFill>
+          <a:ln>
+            <a:noFill/>
+          </a:ln>
+        </p:spPr>
+        <p:style>
+          <a:lnRef idx="1">
+            <a:schemeClr val="accent1"/>
+          </a:lnRef>
+          <a:fillRef idx="3">
+            <a:schemeClr val="accent1"/>
+          </a:fillRef>
+          <a:effectRef idx="2">
+            <a:schemeClr val="accent1"/>
+          </a:effectRef>
+          <a:fontRef idx="minor">
+            <a:schemeClr val="lt1"/>
+          </a:fontRef>
+        </p:style>
+        <p:txBody>
+          <a:bodyPr rtlCol="0" anchor="ctr"/>
+          <a:lstStyle/>
+          <a:p>
+            <a:pPr algn="ctr"/>
+          </a:p>
+        </p:txBody>
+      </p:sp>
+      <p:sp>
+        <p:nvSpPr>
+          <p:cNvPr id="33" name="Rectangle 32"/>
+          <p:cNvSpPr/>
+          <p:nvPr/>
+        </p:nvSpPr>
+        <p:spPr>
+          <a:xfrm>
+            <a:off x="7151046" y="4205874"/>
+            <a:ext cx="4354849" cy="25400"/>
+          </a:xfrm>
+          <a:prstGeom prst="rect">
+            <a:avLst/>
+          </a:prstGeom>
+          <a:solidFill>
+            <a:srgbClr val="0A0A0A"/>
+          </a:solidFill>
+          <a:ln>
+            <a:noFill/>
+          </a:ln>
+        </p:spPr>
+        <p:style>
+          <a:lnRef idx="1">
+            <a:schemeClr val="accent1"/>
+          </a:lnRef>
+          <a:fillRef idx="3">
+            <a:schemeClr val="accent1"/>
+          </a:fillRef>
+          <a:effectRef idx="2">
+            <a:schemeClr val="accent1"/>
+          </a:effectRef>
+          <a:fontRef idx="minor">
+            <a:schemeClr val="lt1"/>
+          </a:fontRef>
+        </p:style>
+        <p:txBody>
+          <a:bodyPr rtlCol="0" anchor="ctr"/>
+          <a:lstStyle/>
+          <a:p>
+            <a:pPr algn="ctr"/>
+          </a:p>
+        </p:txBody>
+      </p:sp>
+      <p:sp>
+        <p:nvSpPr>
+          <p:cNvPr id="34" name="TextBox 33"/>
+          <p:cNvSpPr txBox="1"/>
+          <p:nvPr/>
+        </p:nvSpPr>
+        <p:spPr>
+          <a:xfrm>
+            <a:off x="7151046" y="4279026"/>
+            <a:ext cx="4354849" cy="201168"/>
+          </a:xfrm>
+          <a:prstGeom prst="rect">
+            <a:avLst/>
+          </a:prstGeom>
+          <a:noFill/>
+        </p:spPr>
+        <p:txBody>
+          <a:bodyPr wrap="none">
+            <a:spAutoFit/>
+          </a:bodyPr>
+          <a:lstStyle/>
+          <a:p>
+            <a:r>
+              <a:rPr sz="800" b="1">
+                <a:solidFill>
+                  <a:srgbClr val="0014FF"/>
+                </a:solidFill>
+                <a:latin typeface="Consolas"/>
+              </a:rPr>
+              <a:t>▸ ONE SIGNAL</a:t>
+            </a:r>
+          </a:p>
+        </p:txBody>
+      </p:sp>
+      <p:sp>
+        <p:nvSpPr>
+          <p:cNvPr id="35" name="Rectangle 34"/>
+          <p:cNvSpPr/>
+          <p:nvPr/>
+        </p:nvSpPr>
+        <p:spPr>
+          <a:xfrm>
+            <a:off x="7151046" y="4516770"/>
+            <a:ext cx="4354849" cy="384048"/>
+          </a:xfrm>
+          <a:prstGeom prst="rect">
+            <a:avLst/>
+          </a:prstGeom>
+          <a:solidFill>
+            <a:srgbClr val="F5F6FF"/>
+          </a:solidFill>
+          <a:ln w="25400">
+            <a:solidFill>
+              <a:srgbClr val="0014FF"/>
+            </a:solidFill>
+          </a:ln>
+        </p:spPr>
+        <p:style>
+          <a:lnRef idx="1">
+            <a:schemeClr val="accent1"/>
+          </a:lnRef>
+          <a:fillRef idx="3">
+            <a:schemeClr val="accent1"/>
+          </a:fillRef>
+          <a:effectRef idx="2">
+            <a:schemeClr val="accent1"/>
+          </a:effectRef>
+          <a:fontRef idx="minor">
+            <a:schemeClr val="lt1"/>
+          </a:fontRef>
+        </p:style>
+        <p:txBody>
+          <a:bodyPr rtlCol="0" anchor="ctr"/>
+          <a:lstStyle/>
+          <a:p>
+            <a:pPr algn="ctr"/>
+          </a:p>
+        </p:txBody>
+      </p:sp>
+      <p:sp>
+        <p:nvSpPr>
+          <p:cNvPr id="36" name="Rectangle 35"/>
+          <p:cNvSpPr/>
+          <p:nvPr/>
+        </p:nvSpPr>
+        <p:spPr>
+          <a:xfrm>
+            <a:off x="7151046" y="4516770"/>
+            <a:ext cx="63500" cy="384048"/>
+          </a:xfrm>
+          <a:prstGeom prst="rect">
+            <a:avLst/>
+          </a:prstGeom>
+          <a:solidFill>
+            <a:srgbClr val="FFDD00"/>
+          </a:solidFill>
+          <a:ln>
+            <a:noFill/>
+          </a:ln>
+        </p:spPr>
+        <p:style>
+          <a:lnRef idx="1">
+            <a:schemeClr val="accent1"/>
+          </a:lnRef>
+          <a:fillRef idx="3">
+            <a:schemeClr val="accent1"/>
+          </a:fillRef>
+          <a:effectRef idx="2">
+            <a:schemeClr val="accent1"/>
+          </a:effectRef>
+          <a:fontRef idx="minor">
+            <a:schemeClr val="lt1"/>
+          </a:fontRef>
+        </p:style>
+        <p:txBody>
+          <a:bodyPr rtlCol="0" anchor="ctr"/>
+          <a:lstStyle/>
+          <a:p>
+            <a:pPr algn="ctr"/>
+          </a:p>
+        </p:txBody>
+      </p:sp>
+      <p:sp>
+        <p:nvSpPr>
+          <p:cNvPr id="37" name="TextBox 36"/>
+          <p:cNvSpPr txBox="1"/>
+          <p:nvPr/>
+        </p:nvSpPr>
+        <p:spPr>
+          <a:xfrm>
+            <a:off x="7260774" y="4567570"/>
+            <a:ext cx="4226833" cy="307848"/>
+          </a:xfrm>
+          <a:prstGeom prst="rect">
+            <a:avLst/>
+          </a:prstGeom>
+          <a:noFill/>
+        </p:spPr>
+        <p:txBody>
+          <a:bodyPr wrap="none">
+            <a:spAutoFit/>
+          </a:bodyPr>
+          <a:lstStyle/>
+          <a:p>
+            <a:r>
+              <a:rPr sz="900" b="1">
+                <a:solidFill>
+                  <a:srgbClr val="0A0A0A"/>
+                </a:solidFill>
+                <a:latin typeface="Georgia"/>
+              </a:rPr>
+              <a:t>Budget approved · expansion signal</a:t>
+            </a:r>
+          </a:p>
+        </p:txBody>
+      </p:sp>
+      <p:sp>
+        <p:nvSpPr>
+          <p:cNvPr id="38" name="Oval 37"/>
+          <p:cNvSpPr/>
+          <p:nvPr/>
+        </p:nvSpPr>
+        <p:spPr>
+          <a:xfrm>
+            <a:off x="7151046" y="5111130"/>
+            <a:ext cx="182880" cy="182880"/>
+          </a:xfrm>
+          <a:prstGeom prst="ellipse">
+            <a:avLst/>
+          </a:prstGeom>
+          <a:solidFill>
+            <a:srgbClr val="FAFAFA"/>
+          </a:solidFill>
+          <a:ln w="12700">
+            <a:solidFill>
+              <a:srgbClr val="0A0A0A"/>
+            </a:solidFill>
+          </a:ln>
+        </p:spPr>
+        <p:style>
+          <a:lnRef idx="1">
+            <a:schemeClr val="accent1"/>
+          </a:lnRef>
+          <a:fillRef idx="3">
+            <a:schemeClr val="accent1"/>
+          </a:fillRef>
+          <a:effectRef idx="2">
+            <a:schemeClr val="accent1"/>
+          </a:effectRef>
+          <a:fontRef idx="minor">
+            <a:schemeClr val="lt1"/>
+          </a:fontRef>
+        </p:style>
+        <p:txBody>
+          <a:bodyPr rtlCol="0" anchor="ctr"/>
+          <a:lstStyle/>
+          <a:p>
+            <a:pPr algn="ctr"/>
+          </a:p>
+        </p:txBody>
+      </p:sp>
+      <p:sp>
+        <p:nvSpPr>
+          <p:cNvPr id="39" name="Rectangle 38"/>
+          <p:cNvSpPr/>
+          <p:nvPr/>
+        </p:nvSpPr>
+        <p:spPr>
+          <a:xfrm>
+            <a:off x="7140886" y="5189870"/>
+            <a:ext cx="203200" cy="12700"/>
+          </a:xfrm>
+          <a:prstGeom prst="rect">
+            <a:avLst/>
+          </a:prstGeom>
+          <a:solidFill>
+            <a:srgbClr val="0A0A0A"/>
+          </a:solidFill>
+          <a:ln>
+            <a:noFill/>
+          </a:ln>
+        </p:spPr>
+        <p:style>
+          <a:lnRef idx="1">
+            <a:schemeClr val="accent1"/>
+          </a:lnRef>
+          <a:fillRef idx="3">
+            <a:schemeClr val="accent1"/>
+          </a:fillRef>
+          <a:effectRef idx="2">
+            <a:schemeClr val="accent1"/>
+          </a:effectRef>
+          <a:fontRef idx="minor">
+            <a:schemeClr val="lt1"/>
+          </a:fontRef>
+        </p:style>
+        <p:txBody>
+          <a:bodyPr rtlCol="0" anchor="ctr"/>
+          <a:lstStyle/>
+          <a:p>
+            <a:pPr algn="ctr"/>
+          </a:p>
+        </p:txBody>
+      </p:sp>
+      <p:sp>
+        <p:nvSpPr>
+          <p:cNvPr id="40" name="Oval 39"/>
+          <p:cNvSpPr/>
+          <p:nvPr/>
+        </p:nvSpPr>
+        <p:spPr>
+          <a:xfrm>
+            <a:off x="8805888" y="5111130"/>
+            <a:ext cx="182880" cy="182880"/>
+          </a:xfrm>
+          <a:prstGeom prst="ellipse">
+            <a:avLst/>
+          </a:prstGeom>
+          <a:solidFill>
+            <a:srgbClr val="FAFAFA"/>
+          </a:solidFill>
+          <a:ln w="12700">
+            <a:solidFill>
+              <a:srgbClr val="0A0A0A"/>
+            </a:solidFill>
+          </a:ln>
+        </p:spPr>
+        <p:style>
+          <a:lnRef idx="1">
+            <a:schemeClr val="accent1"/>
+          </a:lnRef>
+          <a:fillRef idx="3">
+            <a:schemeClr val="accent1"/>
+          </a:fillRef>
+          <a:effectRef idx="2">
+            <a:schemeClr val="accent1"/>
+          </a:effectRef>
+          <a:fontRef idx="minor">
+            <a:schemeClr val="lt1"/>
+          </a:fontRef>
+        </p:style>
+        <p:txBody>
+          <a:bodyPr rtlCol="0" anchor="ctr"/>
+          <a:lstStyle/>
+          <a:p>
+            <a:pPr algn="ctr"/>
+          </a:p>
+        </p:txBody>
+      </p:sp>
+      <p:sp>
+        <p:nvSpPr>
+          <p:cNvPr id="41" name="Rectangle 40"/>
+          <p:cNvSpPr/>
+          <p:nvPr/>
+        </p:nvSpPr>
+        <p:spPr>
+          <a:xfrm>
+            <a:off x="8795728" y="5189870"/>
+            <a:ext cx="203200" cy="12700"/>
+          </a:xfrm>
+          <a:prstGeom prst="rect">
+            <a:avLst/>
+          </a:prstGeom>
+          <a:solidFill>
+            <a:srgbClr val="0A0A0A"/>
+          </a:solidFill>
+          <a:ln>
+            <a:noFill/>
+          </a:ln>
+        </p:spPr>
+        <p:style>
+          <a:lnRef idx="1">
+            <a:schemeClr val="accent1"/>
+          </a:lnRef>
+          <a:fillRef idx="3">
+            <a:schemeClr val="accent1"/>
+          </a:fillRef>
+          <a:effectRef idx="2">
+            <a:schemeClr val="accent1"/>
+          </a:effectRef>
+          <a:fontRef idx="minor">
+            <a:schemeClr val="lt1"/>
+          </a:fontRef>
+        </p:style>
+        <p:txBody>
+          <a:bodyPr rtlCol="0" anchor="ctr"/>
+          <a:lstStyle/>
+          <a:p>
+            <a:pPr algn="ctr"/>
+          </a:p>
+        </p:txBody>
+      </p:sp>
+      <p:sp>
+        <p:nvSpPr>
+          <p:cNvPr id="42" name="Oval 41"/>
+          <p:cNvSpPr/>
+          <p:nvPr/>
+        </p:nvSpPr>
+        <p:spPr>
+          <a:xfrm>
+            <a:off x="10460731" y="5111130"/>
+            <a:ext cx="182880" cy="182880"/>
+          </a:xfrm>
+          <a:prstGeom prst="ellipse">
+            <a:avLst/>
+          </a:prstGeom>
+          <a:solidFill>
+            <a:srgbClr val="FAFAFA"/>
+          </a:solidFill>
+          <a:ln w="12700">
+            <a:solidFill>
+              <a:srgbClr val="0A0A0A"/>
+            </a:solidFill>
+          </a:ln>
+        </p:spPr>
+        <p:style>
+          <a:lnRef idx="1">
+            <a:schemeClr val="accent1"/>
+          </a:lnRef>
+          <a:fillRef idx="3">
+            <a:schemeClr val="accent1"/>
+          </a:fillRef>
+          <a:effectRef idx="2">
+            <a:schemeClr val="accent1"/>
+          </a:effectRef>
+          <a:fontRef idx="minor">
+            <a:schemeClr val="lt1"/>
+          </a:fontRef>
+        </p:style>
+        <p:txBody>
+          <a:bodyPr rtlCol="0" anchor="ctr"/>
+          <a:lstStyle/>
+          <a:p>
+            <a:pPr algn="ctr"/>
+          </a:p>
+        </p:txBody>
+      </p:sp>
+      <p:sp>
+        <p:nvSpPr>
+          <p:cNvPr id="43" name="Rectangle 42"/>
+          <p:cNvSpPr/>
+          <p:nvPr/>
+        </p:nvSpPr>
+        <p:spPr>
+          <a:xfrm>
+            <a:off x="10450571" y="5189870"/>
+            <a:ext cx="203200" cy="12700"/>
+          </a:xfrm>
+          <a:prstGeom prst="rect">
+            <a:avLst/>
+          </a:prstGeom>
+          <a:solidFill>
+            <a:srgbClr val="0A0A0A"/>
+          </a:solidFill>
+          <a:ln>
+            <a:noFill/>
+          </a:ln>
+        </p:spPr>
+        <p:style>
+          <a:lnRef idx="1">
+            <a:schemeClr val="accent1"/>
+          </a:lnRef>
+          <a:fillRef idx="3">
+            <a:schemeClr val="accent1"/>
+          </a:fillRef>
+          <a:effectRef idx="2">
+            <a:schemeClr val="accent1"/>
+          </a:effectRef>
+          <a:fontRef idx="minor">
+            <a:schemeClr val="lt1"/>
+          </a:fontRef>
+        </p:style>
+        <p:txBody>
+          <a:bodyPr rtlCol="0" anchor="ctr"/>
+          <a:lstStyle/>
+          <a:p>
+            <a:pPr algn="ctr"/>
+          </a:p>
+        </p:txBody>
+      </p:sp>
+      <p:sp>
+        <p:nvSpPr>
+          <p:cNvPr id="44" name="Rectangle 43"/>
+          <p:cNvSpPr/>
+          <p:nvPr/>
+        </p:nvSpPr>
+        <p:spPr>
+          <a:xfrm rot="19500000">
+            <a:off x="11002975" y="5156850"/>
+            <a:ext cx="12700" cy="320040"/>
+          </a:xfrm>
+          <a:prstGeom prst="rect">
+            <a:avLst/>
+          </a:prstGeom>
+          <a:solidFill>
+            <a:srgbClr val="E0E0E0"/>
+          </a:solidFill>
+          <a:ln>
+            <a:noFill/>
+          </a:ln>
+        </p:spPr>
+        <p:style>
+          <a:lnRef idx="1">
+            <a:schemeClr val="accent1"/>
+          </a:lnRef>
+          <a:fillRef idx="3">
+            <a:schemeClr val="accent1"/>
+          </a:fillRef>
+          <a:effectRef idx="2">
+            <a:schemeClr val="accent1"/>
+          </a:effectRef>
+          <a:fontRef idx="minor">
+            <a:schemeClr val="lt1"/>
+          </a:fontRef>
+        </p:style>
+        <p:txBody>
+          <a:bodyPr rtlCol="0" anchor="ctr"/>
+          <a:lstStyle/>
+          <a:p>
+            <a:pPr algn="ctr"/>
+          </a:p>
+        </p:txBody>
+      </p:sp>
+      <p:sp>
+        <p:nvSpPr>
+          <p:cNvPr id="45" name="Rectangle 44"/>
+          <p:cNvSpPr/>
+          <p:nvPr/>
+        </p:nvSpPr>
+        <p:spPr>
+          <a:xfrm rot="19500000">
+            <a:off x="11079175" y="5233050"/>
+            <a:ext cx="12700" cy="320040"/>
+          </a:xfrm>
+          <a:prstGeom prst="rect">
+            <a:avLst/>
+          </a:prstGeom>
+          <a:solidFill>
+            <a:srgbClr val="E0E0E0"/>
+          </a:solidFill>
+          <a:ln>
+            <a:noFill/>
+          </a:ln>
+        </p:spPr>
+        <p:style>
+          <a:lnRef idx="1">
+            <a:schemeClr val="accent1"/>
+          </a:lnRef>
+          <a:fillRef idx="3">
+            <a:schemeClr val="accent1"/>
+          </a:fillRef>
+          <a:effectRef idx="2">
+            <a:schemeClr val="accent1"/>
+          </a:effectRef>
+          <a:fontRef idx="minor">
+            <a:schemeClr val="lt1"/>
+          </a:fontRef>
+        </p:style>
+        <p:txBody>
+          <a:bodyPr rtlCol="0" anchor="ctr"/>
+          <a:lstStyle/>
+          <a:p>
+            <a:pPr algn="ctr"/>
+          </a:p>
+        </p:txBody>
+      </p:sp>
+      <p:sp>
+        <p:nvSpPr>
+          <p:cNvPr id="46" name="Rectangle 45"/>
+          <p:cNvSpPr/>
+          <p:nvPr/>
+        </p:nvSpPr>
+        <p:spPr>
+          <a:xfrm rot="19500000">
+            <a:off x="11155375" y="5309250"/>
+            <a:ext cx="12700" cy="320040"/>
+          </a:xfrm>
+          <a:prstGeom prst="rect">
+            <a:avLst/>
+          </a:prstGeom>
+          <a:solidFill>
+            <a:srgbClr val="E0E0E0"/>
+          </a:solidFill>
+          <a:ln>
+            <a:noFill/>
+          </a:ln>
+        </p:spPr>
+        <p:style>
+          <a:lnRef idx="1">
+            <a:schemeClr val="accent1"/>
+          </a:lnRef>
+          <a:fillRef idx="3">
+            <a:schemeClr val="accent1"/>
+          </a:fillRef>
+          <a:effectRef idx="2">
+            <a:schemeClr val="accent1"/>
+          </a:effectRef>
+          <a:fontRef idx="minor">
+            <a:schemeClr val="lt1"/>
+          </a:fontRef>
+        </p:style>
+        <p:txBody>
+          <a:bodyPr rtlCol="0" anchor="ctr"/>
+          <a:lstStyle/>
+          <a:p>
+            <a:pPr algn="ctr"/>
+          </a:p>
+        </p:txBody>
+      </p:sp>
+      <p:sp>
+        <p:nvSpPr>
+          <p:cNvPr id="47" name="Rectangle 46"/>
+          <p:cNvSpPr/>
+          <p:nvPr/>
+        </p:nvSpPr>
+        <p:spPr>
+          <a:xfrm rot="19500000">
+            <a:off x="11231575" y="5385450"/>
+            <a:ext cx="12700" cy="320040"/>
+          </a:xfrm>
+          <a:prstGeom prst="rect">
+            <a:avLst/>
+          </a:prstGeom>
+          <a:solidFill>
+            <a:srgbClr val="E0E0E0"/>
+          </a:solidFill>
+          <a:ln>
+            <a:noFill/>
+          </a:ln>
+        </p:spPr>
+        <p:style>
+          <a:lnRef idx="1">
+            <a:schemeClr val="accent1"/>
+          </a:lnRef>
+          <a:fillRef idx="3">
+            <a:schemeClr val="accent1"/>
+          </a:fillRef>
+          <a:effectRef idx="2">
+            <a:schemeClr val="accent1"/>
+          </a:effectRef>
+          <a:fontRef idx="minor">
+            <a:schemeClr val="lt1"/>
+          </a:fontRef>
+        </p:style>
+        <p:txBody>
+          <a:bodyPr rtlCol="0" anchor="ctr"/>
+          <a:lstStyle/>
+          <a:p>
+            <a:pPr algn="ctr"/>
+          </a:p>
+        </p:txBody>
+      </p:sp>
+      <p:sp>
+        <p:nvSpPr>
+          <p:cNvPr id="48" name="Rectangle 47"/>
+          <p:cNvSpPr/>
+          <p:nvPr/>
+        </p:nvSpPr>
+        <p:spPr>
+          <a:xfrm rot="19500000">
+            <a:off x="11307775" y="5461650"/>
+            <a:ext cx="12700" cy="320040"/>
+          </a:xfrm>
+          <a:prstGeom prst="rect">
+            <a:avLst/>
+          </a:prstGeom>
+          <a:solidFill>
+            <a:srgbClr val="E0E0E0"/>
+          </a:solidFill>
+          <a:ln>
+            <a:noFill/>
+          </a:ln>
+        </p:spPr>
+        <p:style>
+          <a:lnRef idx="1">
+            <a:schemeClr val="accent1"/>
+          </a:lnRef>
+          <a:fillRef idx="3">
+            <a:schemeClr val="accent1"/>
+          </a:fillRef>
+          <a:effectRef idx="2">
+            <a:schemeClr val="accent1"/>
+          </a:effectRef>
+          <a:fontRef idx="minor">
+            <a:schemeClr val="lt1"/>
+          </a:fontRef>
+        </p:style>
+        <p:txBody>
+          <a:bodyPr rtlCol="0" anchor="ctr"/>
+          <a:lstStyle/>
+          <a:p>
+            <a:pPr algn="ctr"/>
+          </a:p>
+        </p:txBody>
+      </p:sp>
+      <p:sp>
+        <p:nvSpPr>
+          <p:cNvPr id="49" name="Rectangle 48"/>
+          <p:cNvSpPr/>
+          <p:nvPr/>
+        </p:nvSpPr>
+        <p:spPr>
+          <a:xfrm rot="19500000">
+            <a:off x="11383975" y="5537850"/>
+            <a:ext cx="12700" cy="320040"/>
+          </a:xfrm>
+          <a:prstGeom prst="rect">
+            <a:avLst/>
+          </a:prstGeom>
+          <a:solidFill>
+            <a:srgbClr val="E0E0E0"/>
+          </a:solidFill>
+          <a:ln>
+            <a:noFill/>
+          </a:ln>
+        </p:spPr>
+        <p:style>
+          <a:lnRef idx="1">
+            <a:schemeClr val="accent1"/>
+          </a:lnRef>
+          <a:fillRef idx="3">
+            <a:schemeClr val="accent1"/>
+          </a:fillRef>
+          <a:effectRef idx="2">
+            <a:schemeClr val="accent1"/>
+          </a:effectRef>
+          <a:fontRef idx="minor">
+            <a:schemeClr val="lt1"/>
+          </a:fontRef>
+        </p:style>
+        <p:txBody>
+          <a:bodyPr rtlCol="0" anchor="ctr"/>
+          <a:lstStyle/>
+          <a:p>
+            <a:pPr algn="ctr"/>
+          </a:p>
+        </p:txBody>
+      </p:sp>
+      <p:sp>
+        <p:nvSpPr>
+          <p:cNvPr id="50" name="TextBox 49"/>
+          <p:cNvSpPr txBox="1"/>
+          <p:nvPr/>
+        </p:nvSpPr>
+        <p:spPr>
+          <a:xfrm>
+            <a:off x="7151046" y="5861304"/>
+            <a:ext cx="4354849" cy="292608"/>
+          </a:xfrm>
+          <a:prstGeom prst="rect">
+            <a:avLst/>
+          </a:prstGeom>
+          <a:noFill/>
+        </p:spPr>
+        <p:txBody>
+          <a:bodyPr wrap="none">
+            <a:spAutoFit/>
+          </a:bodyPr>
+          <a:lstStyle/>
+          <a:p>
+            <a:pPr algn="ctr"/>
+            <a:r>
+              <a:rPr sz="700" b="0">
+                <a:solidFill>
+                  <a:srgbClr val="5C5C5C"/>
+                </a:solidFill>
+                <a:latin typeface="Consolas"/>
+              </a:rPr>
+              <a:t>Fig. 1 — Signal vs. noise at the desk</a:t>
+            </a:r>
+          </a:p>
+        </p:txBody>
+      </p:sp>
+      <p:sp>
+        <p:nvSpPr>
+          <p:cNvPr id="51" name="Rectangle 50"/>
+          <p:cNvSpPr/>
+          <p:nvPr/>
+        </p:nvSpPr>
+        <p:spPr>
+          <a:xfrm>
+            <a:off x="502920" y="6473952"/>
+            <a:ext cx="11185855" cy="12700"/>
+          </a:xfrm>
+          <a:prstGeom prst="rect">
+            <a:avLst/>
+          </a:prstGeom>
+          <a:solidFill>
+            <a:srgbClr val="0A0A0A"/>
+          </a:solidFill>
+          <a:ln>
+            <a:noFill/>
+          </a:ln>
+        </p:spPr>
+        <p:style>
+          <a:lnRef idx="1">
+            <a:schemeClr val="accent1"/>
+          </a:lnRef>
+          <a:fillRef idx="3">
+            <a:schemeClr val="accent1"/>
+          </a:fillRef>
+          <a:effectRef idx="2">
+            <a:schemeClr val="accent1"/>
+          </a:effectRef>
+          <a:fontRef idx="minor">
+            <a:schemeClr val="lt1"/>
+          </a:fontRef>
+        </p:style>
+        <p:txBody>
+          <a:bodyPr rtlCol="0" anchor="ctr"/>
+          <a:lstStyle/>
+          <a:p>
+            <a:pPr algn="ctr"/>
+          </a:p>
+        </p:txBody>
+      </p:sp>
+      <p:sp>
+        <p:nvSpPr>
+          <p:cNvPr id="52" name="Rectangle 51"/>
+          <p:cNvSpPr/>
+          <p:nvPr/>
+        </p:nvSpPr>
+        <p:spPr>
+          <a:xfrm>
+            <a:off x="502920" y="6524752"/>
+            <a:ext cx="11185855" cy="12700"/>
+          </a:xfrm>
+          <a:prstGeom prst="rect">
+            <a:avLst/>
+          </a:prstGeom>
+          <a:solidFill>
+            <a:srgbClr val="E0E0E0"/>
+          </a:solidFill>
+          <a:ln>
+            <a:noFill/>
+          </a:ln>
+        </p:spPr>
+        <p:style>
+          <a:lnRef idx="1">
+            <a:schemeClr val="accent1"/>
+          </a:lnRef>
+          <a:fillRef idx="3">
+            <a:schemeClr val="accent1"/>
+          </a:fillRef>
+          <a:effectRef idx="2">
+            <a:schemeClr val="accent1"/>
+          </a:effectRef>
+          <a:fontRef idx="minor">
+            <a:schemeClr val="lt1"/>
+          </a:fontRef>
+        </p:style>
+        <p:txBody>
+          <a:bodyPr rtlCol="0" anchor="ctr"/>
+          <a:lstStyle/>
+          <a:p>
+            <a:pPr algn="ctr"/>
+          </a:p>
+        </p:txBody>
+      </p:sp>
+      <p:sp>
+        <p:nvSpPr>
+          <p:cNvPr id="53" name="TextBox 52"/>
           <p:cNvSpPr txBox="1"/>
           <p:nvPr/>
         </p:nvSpPr>

</xml_diff>